<commit_message>
update to 11 page
</commit_message>
<xml_diff>
--- a/source/Alphafold.pptx
+++ b/source/Alphafold.pptx
@@ -259,7 +259,7 @@
           <a:p>
             <a:fld id="{250E99D2-494C-4EDB-8DE3-59EFC1FDB0F4}" type="datetimeFigureOut">
               <a:rPr lang="zh-CN" altLang="en-US" smtClean="0"/>
-              <a:t>2025/12/16</a:t>
+              <a:t>2025/12/17</a:t>
             </a:fld>
             <a:endParaRPr lang="zh-CN" altLang="en-US"/>
           </a:p>
@@ -457,7 +457,7 @@
           <a:p>
             <a:fld id="{250E99D2-494C-4EDB-8DE3-59EFC1FDB0F4}" type="datetimeFigureOut">
               <a:rPr lang="zh-CN" altLang="en-US" smtClean="0"/>
-              <a:t>2025/12/16</a:t>
+              <a:t>2025/12/17</a:t>
             </a:fld>
             <a:endParaRPr lang="zh-CN" altLang="en-US"/>
           </a:p>
@@ -665,7 +665,7 @@
           <a:p>
             <a:fld id="{250E99D2-494C-4EDB-8DE3-59EFC1FDB0F4}" type="datetimeFigureOut">
               <a:rPr lang="zh-CN" altLang="en-US" smtClean="0"/>
-              <a:t>2025/12/16</a:t>
+              <a:t>2025/12/17</a:t>
             </a:fld>
             <a:endParaRPr lang="zh-CN" altLang="en-US"/>
           </a:p>
@@ -863,7 +863,7 @@
           <a:p>
             <a:fld id="{250E99D2-494C-4EDB-8DE3-59EFC1FDB0F4}" type="datetimeFigureOut">
               <a:rPr lang="zh-CN" altLang="en-US" smtClean="0"/>
-              <a:t>2025/12/16</a:t>
+              <a:t>2025/12/17</a:t>
             </a:fld>
             <a:endParaRPr lang="zh-CN" altLang="en-US"/>
           </a:p>
@@ -1138,7 +1138,7 @@
           <a:p>
             <a:fld id="{250E99D2-494C-4EDB-8DE3-59EFC1FDB0F4}" type="datetimeFigureOut">
               <a:rPr lang="zh-CN" altLang="en-US" smtClean="0"/>
-              <a:t>2025/12/16</a:t>
+              <a:t>2025/12/17</a:t>
             </a:fld>
             <a:endParaRPr lang="zh-CN" altLang="en-US"/>
           </a:p>
@@ -1403,7 +1403,7 @@
           <a:p>
             <a:fld id="{250E99D2-494C-4EDB-8DE3-59EFC1FDB0F4}" type="datetimeFigureOut">
               <a:rPr lang="zh-CN" altLang="en-US" smtClean="0"/>
-              <a:t>2025/12/16</a:t>
+              <a:t>2025/12/17</a:t>
             </a:fld>
             <a:endParaRPr lang="zh-CN" altLang="en-US"/>
           </a:p>
@@ -1815,7 +1815,7 @@
           <a:p>
             <a:fld id="{250E99D2-494C-4EDB-8DE3-59EFC1FDB0F4}" type="datetimeFigureOut">
               <a:rPr lang="zh-CN" altLang="en-US" smtClean="0"/>
-              <a:t>2025/12/16</a:t>
+              <a:t>2025/12/17</a:t>
             </a:fld>
             <a:endParaRPr lang="zh-CN" altLang="en-US"/>
           </a:p>
@@ -1956,7 +1956,7 @@
           <a:p>
             <a:fld id="{250E99D2-494C-4EDB-8DE3-59EFC1FDB0F4}" type="datetimeFigureOut">
               <a:rPr lang="zh-CN" altLang="en-US" smtClean="0"/>
-              <a:t>2025/12/16</a:t>
+              <a:t>2025/12/17</a:t>
             </a:fld>
             <a:endParaRPr lang="zh-CN" altLang="en-US"/>
           </a:p>
@@ -2069,7 +2069,7 @@
           <a:p>
             <a:fld id="{250E99D2-494C-4EDB-8DE3-59EFC1FDB0F4}" type="datetimeFigureOut">
               <a:rPr lang="zh-CN" altLang="en-US" smtClean="0"/>
-              <a:t>2025/12/16</a:t>
+              <a:t>2025/12/17</a:t>
             </a:fld>
             <a:endParaRPr lang="zh-CN" altLang="en-US"/>
           </a:p>
@@ -2380,7 +2380,7 @@
           <a:p>
             <a:fld id="{250E99D2-494C-4EDB-8DE3-59EFC1FDB0F4}" type="datetimeFigureOut">
               <a:rPr lang="zh-CN" altLang="en-US" smtClean="0"/>
-              <a:t>2025/12/16</a:t>
+              <a:t>2025/12/17</a:t>
             </a:fld>
             <a:endParaRPr lang="zh-CN" altLang="en-US"/>
           </a:p>
@@ -2668,7 +2668,7 @@
           <a:p>
             <a:fld id="{250E99D2-494C-4EDB-8DE3-59EFC1FDB0F4}" type="datetimeFigureOut">
               <a:rPr lang="zh-CN" altLang="en-US" smtClean="0"/>
-              <a:t>2025/12/16</a:t>
+              <a:t>2025/12/17</a:t>
             </a:fld>
             <a:endParaRPr lang="zh-CN" altLang="en-US"/>
           </a:p>
@@ -2909,7 +2909,7 @@
           <a:p>
             <a:fld id="{250E99D2-494C-4EDB-8DE3-59EFC1FDB0F4}" type="datetimeFigureOut">
               <a:rPr lang="zh-CN" altLang="en-US" smtClean="0"/>
-              <a:t>2025/12/16</a:t>
+              <a:t>2025/12/17</a:t>
             </a:fld>
             <a:endParaRPr lang="zh-CN" altLang="en-US"/>
           </a:p>
@@ -3340,7 +3340,7 @@
         </p:nvGrpSpPr>
         <p:grpSpPr>
           <a:xfrm rot="16200000" flipV="1">
-            <a:off x="4965594" y="1426373"/>
+            <a:off x="4965594" y="1540673"/>
             <a:ext cx="1912407" cy="3955205"/>
             <a:chOff x="6730819" y="1098597"/>
             <a:chExt cx="2408844" cy="1595064"/>
@@ -3577,7 +3577,7 @@
         </p:nvGrpSpPr>
         <p:grpSpPr>
           <a:xfrm>
-            <a:off x="6730819" y="1008099"/>
+            <a:off x="6730819" y="1122399"/>
             <a:ext cx="2408844" cy="1802317"/>
             <a:chOff x="6730819" y="1098597"/>
             <a:chExt cx="2408844" cy="1595064"/>
@@ -4141,7 +4141,7 @@
         </p:blipFill>
         <p:spPr>
           <a:xfrm>
-            <a:off x="965775" y="4525090"/>
+            <a:off x="965775" y="4613990"/>
             <a:ext cx="1130621" cy="923821"/>
           </a:xfrm>
           <a:prstGeom prst="rect">
@@ -4168,7 +4168,7 @@
         <p:spPr>
           <a:xfrm>
             <a:off x="1521561" y="4056231"/>
-            <a:ext cx="9525" cy="468859"/>
+            <a:ext cx="9525" cy="557759"/>
           </a:xfrm>
           <a:prstGeom prst="straightConnector1">
             <a:avLst/>
@@ -4210,13 +4210,13 @@
           <p:nvPr>
             <p:extLst>
               <p:ext uri="{D42A27DB-BD31-4B8C-83A1-F6EECF244321}">
-                <p14:modId xmlns:p14="http://schemas.microsoft.com/office/powerpoint/2010/main" val="3095975163"/>
+                <p14:modId xmlns:p14="http://schemas.microsoft.com/office/powerpoint/2010/main" val="1113635502"/>
               </p:ext>
             </p:extLst>
           </p:nvPr>
         </p:nvGraphicFramePr>
         <p:xfrm>
-          <a:off x="2832445" y="949602"/>
+          <a:off x="2832445" y="1063902"/>
           <a:ext cx="1080000" cy="900000"/>
         </p:xfrm>
         <a:graphic>
@@ -6102,7 +6102,7 @@
         </p:nvSpPr>
         <p:spPr>
           <a:xfrm>
-            <a:off x="4862869" y="1039602"/>
+            <a:off x="4862869" y="1153902"/>
             <a:ext cx="753247" cy="720000"/>
           </a:xfrm>
           <a:prstGeom prst="roundRect">
@@ -6181,7 +6181,7 @@
         </p:nvSpPr>
         <p:spPr>
           <a:xfrm>
-            <a:off x="6741118" y="1039602"/>
+            <a:off x="6741118" y="1153902"/>
             <a:ext cx="757185" cy="720000"/>
           </a:xfrm>
           <a:prstGeom prst="roundRect">
@@ -6260,7 +6260,7 @@
         </p:nvSpPr>
         <p:spPr>
           <a:xfrm>
-            <a:off x="6241968" y="2176153"/>
+            <a:off x="6241968" y="2290453"/>
             <a:ext cx="1760832" cy="720000"/>
           </a:xfrm>
           <a:prstGeom prst="roundRect">
@@ -6339,7 +6339,7 @@
         </p:nvSpPr>
         <p:spPr>
           <a:xfrm>
-            <a:off x="8623307" y="1039602"/>
+            <a:off x="8623307" y="1153902"/>
             <a:ext cx="847544" cy="720000"/>
           </a:xfrm>
           <a:prstGeom prst="roundRect">
@@ -6422,13 +6422,13 @@
           <p:nvPr>
             <p:extLst>
               <p:ext uri="{D42A27DB-BD31-4B8C-83A1-F6EECF244321}">
-                <p14:modId xmlns:p14="http://schemas.microsoft.com/office/powerpoint/2010/main" val="243926330"/>
+                <p14:modId xmlns:p14="http://schemas.microsoft.com/office/powerpoint/2010/main" val="29685529"/>
               </p:ext>
             </p:extLst>
           </p:nvPr>
         </p:nvGraphicFramePr>
         <p:xfrm>
-          <a:off x="2832445" y="3177233"/>
+          <a:off x="2832445" y="3291533"/>
           <a:ext cx="1080000" cy="1080000"/>
         </p:xfrm>
         <a:graphic>
@@ -8681,7 +8681,7 @@
         </p:nvSpPr>
         <p:spPr>
           <a:xfrm>
-            <a:off x="5604420" y="3357233"/>
+            <a:off x="5604420" y="3471533"/>
             <a:ext cx="882032" cy="720000"/>
           </a:xfrm>
           <a:prstGeom prst="roundRect">
@@ -8763,7 +8763,7 @@
         </p:nvSpPr>
         <p:spPr>
           <a:xfrm>
-            <a:off x="6657076" y="3357233"/>
+            <a:off x="6657076" y="3471533"/>
             <a:ext cx="846000" cy="720000"/>
           </a:xfrm>
           <a:prstGeom prst="roundRect">
@@ -8842,7 +8842,7 @@
         </p:nvSpPr>
         <p:spPr>
           <a:xfrm>
-            <a:off x="8096436" y="3357233"/>
+            <a:off x="8096436" y="3471533"/>
             <a:ext cx="847543" cy="720000"/>
           </a:xfrm>
           <a:prstGeom prst="roundRect">
@@ -8921,7 +8921,7 @@
         </p:nvSpPr>
         <p:spPr>
           <a:xfrm>
-            <a:off x="4110914" y="3357233"/>
+            <a:off x="4110914" y="3471533"/>
             <a:ext cx="882000" cy="720000"/>
           </a:xfrm>
           <a:prstGeom prst="roundRect">
@@ -9004,13 +9004,13 @@
           <p:nvPr>
             <p:extLst>
               <p:ext uri="{D42A27DB-BD31-4B8C-83A1-F6EECF244321}">
-                <p14:modId xmlns:p14="http://schemas.microsoft.com/office/powerpoint/2010/main" val="1962810067"/>
+                <p14:modId xmlns:p14="http://schemas.microsoft.com/office/powerpoint/2010/main" val="486452023"/>
               </p:ext>
             </p:extLst>
           </p:nvPr>
         </p:nvGraphicFramePr>
         <p:xfrm>
-          <a:off x="10687164" y="949602"/>
+          <a:off x="10687164" y="1063902"/>
           <a:ext cx="1080000" cy="900000"/>
         </p:xfrm>
         <a:graphic>
@@ -10928,13 +10928,13 @@
           <p:nvPr>
             <p:extLst>
               <p:ext uri="{D42A27DB-BD31-4B8C-83A1-F6EECF244321}">
-                <p14:modId xmlns:p14="http://schemas.microsoft.com/office/powerpoint/2010/main" val="4151763453"/>
+                <p14:modId xmlns:p14="http://schemas.microsoft.com/office/powerpoint/2010/main" val="2249410043"/>
               </p:ext>
             </p:extLst>
           </p:nvPr>
         </p:nvGraphicFramePr>
         <p:xfrm>
-          <a:off x="10687164" y="3177233"/>
+          <a:off x="10687164" y="3291533"/>
           <a:ext cx="1080000" cy="1080000"/>
         </p:xfrm>
         <a:graphic>
@@ -13186,7 +13186,7 @@
         </p:nvSpPr>
         <p:spPr>
           <a:xfrm>
-            <a:off x="7949204" y="1039602"/>
+            <a:off x="7949204" y="1153902"/>
             <a:ext cx="223200" cy="720000"/>
           </a:xfrm>
           <a:prstGeom prst="roundRect">
@@ -13255,7 +13255,7 @@
         </p:nvSpPr>
         <p:spPr>
           <a:xfrm>
-            <a:off x="6067017" y="1039602"/>
+            <a:off x="6067017" y="1153902"/>
             <a:ext cx="223200" cy="720000"/>
           </a:xfrm>
           <a:prstGeom prst="roundRect">
@@ -13328,7 +13328,7 @@
         </p:nvCxnSpPr>
         <p:spPr>
           <a:xfrm>
-            <a:off x="3912445" y="1399602"/>
+            <a:off x="3912445" y="1513902"/>
             <a:ext cx="950424" cy="0"/>
           </a:xfrm>
           <a:prstGeom prst="straightConnector1">
@@ -13374,7 +13374,7 @@
         </p:nvCxnSpPr>
         <p:spPr>
           <a:xfrm>
-            <a:off x="5616116" y="1399602"/>
+            <a:off x="5616116" y="1513902"/>
             <a:ext cx="450901" cy="0"/>
           </a:xfrm>
           <a:prstGeom prst="straightConnector1">
@@ -13420,7 +13420,7 @@
         </p:nvCxnSpPr>
         <p:spPr>
           <a:xfrm>
-            <a:off x="6290217" y="1399602"/>
+            <a:off x="6290217" y="1513902"/>
             <a:ext cx="450901" cy="0"/>
           </a:xfrm>
           <a:prstGeom prst="straightConnector1">
@@ -13466,7 +13466,7 @@
         </p:nvCxnSpPr>
         <p:spPr>
           <a:xfrm>
-            <a:off x="7498303" y="1399602"/>
+            <a:off x="7498303" y="1513902"/>
             <a:ext cx="450901" cy="0"/>
           </a:xfrm>
           <a:prstGeom prst="straightConnector1">
@@ -13512,7 +13512,7 @@
         </p:nvCxnSpPr>
         <p:spPr>
           <a:xfrm>
-            <a:off x="8172404" y="1399602"/>
+            <a:off x="8172404" y="1513902"/>
             <a:ext cx="450903" cy="0"/>
           </a:xfrm>
           <a:prstGeom prst="straightConnector1">
@@ -13554,7 +13554,7 @@
         </p:nvSpPr>
         <p:spPr>
           <a:xfrm>
-            <a:off x="5190480" y="3357233"/>
+            <a:off x="5190480" y="3471533"/>
             <a:ext cx="220609" cy="720000"/>
           </a:xfrm>
           <a:prstGeom prst="roundRect">
@@ -13623,7 +13623,7 @@
         </p:nvSpPr>
         <p:spPr>
           <a:xfrm>
-            <a:off x="7684968" y="3357233"/>
+            <a:off x="7684968" y="3471533"/>
             <a:ext cx="224197" cy="720000"/>
           </a:xfrm>
           <a:prstGeom prst="roundRect">
@@ -13692,7 +13692,7 @@
         </p:nvSpPr>
         <p:spPr>
           <a:xfrm>
-            <a:off x="9139662" y="3357233"/>
+            <a:off x="9139662" y="3471533"/>
             <a:ext cx="224198" cy="720000"/>
           </a:xfrm>
           <a:prstGeom prst="roundRect">
@@ -13765,7 +13765,7 @@
         </p:nvCxnSpPr>
         <p:spPr>
           <a:xfrm>
-            <a:off x="4992914" y="3717233"/>
+            <a:off x="4992914" y="3831533"/>
             <a:ext cx="197566" cy="0"/>
           </a:xfrm>
           <a:prstGeom prst="straightConnector1">
@@ -13811,7 +13811,7 @@
         </p:nvCxnSpPr>
         <p:spPr>
           <a:xfrm>
-            <a:off x="5411089" y="3717233"/>
+            <a:off x="5411089" y="3831533"/>
             <a:ext cx="193331" cy="0"/>
           </a:xfrm>
           <a:prstGeom prst="straightConnector1">
@@ -13856,7 +13856,7 @@
         </p:nvCxnSpPr>
         <p:spPr>
           <a:xfrm>
-            <a:off x="6486452" y="3717233"/>
+            <a:off x="6486452" y="3831533"/>
             <a:ext cx="170624" cy="0"/>
           </a:xfrm>
           <a:prstGeom prst="straightConnector1">
@@ -13901,7 +13901,7 @@
         </p:nvCxnSpPr>
         <p:spPr>
           <a:xfrm>
-            <a:off x="7503076" y="3717233"/>
+            <a:off x="7503076" y="3831533"/>
             <a:ext cx="181892" cy="0"/>
           </a:xfrm>
           <a:prstGeom prst="straightConnector1">
@@ -13946,7 +13946,7 @@
         </p:nvCxnSpPr>
         <p:spPr>
           <a:xfrm>
-            <a:off x="7909165" y="3717233"/>
+            <a:off x="7909165" y="3831533"/>
             <a:ext cx="187271" cy="0"/>
           </a:xfrm>
           <a:prstGeom prst="straightConnector1">
@@ -13991,7 +13991,7 @@
         </p:nvCxnSpPr>
         <p:spPr>
           <a:xfrm>
-            <a:off x="8943979" y="3717233"/>
+            <a:off x="8943979" y="3831533"/>
             <a:ext cx="195683" cy="0"/>
           </a:xfrm>
           <a:prstGeom prst="straightConnector1">
@@ -14033,7 +14033,7 @@
         </p:nvSpPr>
         <p:spPr>
           <a:xfrm>
-            <a:off x="9574021" y="3357233"/>
+            <a:off x="9574021" y="3471533"/>
             <a:ext cx="847544" cy="720000"/>
           </a:xfrm>
           <a:prstGeom prst="roundRect">
@@ -14118,7 +14118,7 @@
         </p:nvCxnSpPr>
         <p:spPr>
           <a:xfrm>
-            <a:off x="9363860" y="3717233"/>
+            <a:off x="9363860" y="3831533"/>
             <a:ext cx="210161" cy="0"/>
           </a:xfrm>
           <a:prstGeom prst="straightConnector1">
@@ -14163,7 +14163,7 @@
         </p:nvCxnSpPr>
         <p:spPr>
           <a:xfrm>
-            <a:off x="10421565" y="3717233"/>
+            <a:off x="10421565" y="3831533"/>
             <a:ext cx="265599" cy="0"/>
           </a:xfrm>
           <a:prstGeom prst="straightConnector1">
@@ -14207,7 +14207,7 @@
         </p:nvCxnSpPr>
         <p:spPr>
           <a:xfrm flipV="1">
-            <a:off x="3713480" y="3717233"/>
+            <a:off x="3713480" y="3831533"/>
             <a:ext cx="397434" cy="2268"/>
           </a:xfrm>
           <a:prstGeom prst="straightConnector1">
@@ -14252,7 +14252,7 @@
         </p:nvCxnSpPr>
         <p:spPr>
           <a:xfrm>
-            <a:off x="9470851" y="1399602"/>
+            <a:off x="9470851" y="1513902"/>
             <a:ext cx="1216313" cy="0"/>
           </a:xfrm>
           <a:prstGeom prst="straightConnector1">
@@ -14294,7 +14294,7 @@
         </p:nvSpPr>
         <p:spPr>
           <a:xfrm>
-            <a:off x="2577148" y="2010254"/>
+            <a:off x="2577148" y="2124554"/>
             <a:ext cx="1590595" cy="523220"/>
           </a:xfrm>
           <a:prstGeom prst="rect">
@@ -14347,7 +14347,7 @@
         </p:nvSpPr>
         <p:spPr>
           <a:xfrm>
-            <a:off x="2577148" y="4453906"/>
+            <a:off x="2577148" y="4568206"/>
             <a:ext cx="1590595" cy="523220"/>
           </a:xfrm>
           <a:prstGeom prst="rect">
@@ -14400,7 +14400,7 @@
         </p:nvSpPr>
         <p:spPr>
           <a:xfrm>
-            <a:off x="10431867" y="2107849"/>
+            <a:off x="10431867" y="2222149"/>
             <a:ext cx="1590595" cy="523220"/>
           </a:xfrm>
           <a:prstGeom prst="rect">
@@ -14453,7 +14453,7 @@
         </p:nvSpPr>
         <p:spPr>
           <a:xfrm>
-            <a:off x="10431867" y="4438538"/>
+            <a:off x="10431867" y="4552838"/>
             <a:ext cx="1590595" cy="523220"/>
           </a:xfrm>
           <a:prstGeom prst="rect">
@@ -14506,7 +14506,7 @@
         </p:nvSpPr>
         <p:spPr>
           <a:xfrm>
-            <a:off x="2499463" y="800100"/>
+            <a:off x="2499463" y="914400"/>
             <a:ext cx="9533299" cy="4259580"/>
           </a:xfrm>
           <a:prstGeom prst="rect">
@@ -14559,7 +14559,7 @@
         </p:nvSpPr>
         <p:spPr>
           <a:xfrm>
-            <a:off x="6586343" y="580270"/>
+            <a:off x="6586343" y="694570"/>
             <a:ext cx="1098625" cy="369332"/>
           </a:xfrm>
           <a:prstGeom prst="rect">

</xml_diff>